<commit_message>
Reorganise repo, update README and slide metrics
- Flatten project structure: scripts and outputs moved from python/ to root; old Results/ removed
- Rewrite README with full methodology, results tables, and script-by-script breakdown
- Fix slide 8: RF balanced metrics updated to actual output (F1 0.905, MCC 0.903, Recall 0.854); SMOTE row marked N/A (imbalanced-learn not installed)
- Fix slide 9: disc_power corrected to 0.449, |sep| corrected to 7.79σ for V14
- Fix slide 12: takeaway #2 updated to match corrected RF balanced F1

Co-Authored-By: Claude Sonnet 4.6 <noreply@anthropic.com>
</commit_message>
<xml_diff>
--- a/credit_card_fraud_detection.pptx
+++ b/credit_card_fraud_detection.pptx
@@ -3730,7 +3730,7 @@
                 <a:ea typeface="Calibri" pitchFamily="34" charset="-122"/>
                 <a:cs typeface="Calibri" pitchFamily="34" charset="-120"/>
               </a:rPr>
-              <a:t>Isolation Forest (F1=0.311, PR AUC=0.189) provides a no-label baseline. Adding labels with SMOTE + class-weighted RF pushes F1 to 0.907 — a 3× gain. Use IsoForest where labels are absent; supervised when available.</a:t>
+              <a:t>Isolation Forest (F1=0.311, PR AUC=0.189) provides a no-label baseline. Adding labels with class-weighted RF pushes F1 to 0.905 — a 3× gain. Use IsoForest where labels are absent; supervised when available.</a:t>
             </a:r>
             <a:endParaRPr lang="en-US" sz="1150" dirty="0"/>
           </a:p>
@@ -4684,7 +4684,7 @@
                 <a:ea typeface="Calibri" pitchFamily="34" charset="-122"/>
                 <a:cs typeface="Calibri" pitchFamily="34" charset="-120"/>
               </a:rPr>
-              <a:t> A model that flags nothing achieves 99.83% accuracy — catching zero fraud.  </a:t>
+              <a:t xml:space="preserve"> A model that flags nothing achieves 99.83% accuracy — catching zero fraud.  </a:t>
             </a:r>
             <a:r>
               <a:rPr lang="en-US" sz="1350" b="1" dirty="0">
@@ -4726,7 +4726,7 @@
                 <a:ea typeface="Calibri" pitchFamily="34" charset="-122"/>
                 <a:cs typeface="Calibri" pitchFamily="34" charset="-120"/>
               </a:rPr>
-              <a:t> Reaches 0.955 even with our unsupervised model — inflated by the 284,315-strong majority class.</a:t>
+              <a:t xml:space="preserve"> Reaches 0.955 even with our unsupervised model — inflated by the 284,315-strong majority class.</a:t>
             </a:r>
             <a:endParaRPr lang="en-US" sz="1350" dirty="0"/>
           </a:p>
@@ -4757,7 +4757,7 @@
                 <a:ea typeface="Calibri" pitchFamily="34" charset="-122"/>
                 <a:cs typeface="Calibri" pitchFamily="34" charset="-120"/>
               </a:rPr>
-              <a:t> Precision, Recall, F1, PR AUC, and MCC — all calibrated to the minority (fraud) class.</a:t>
+              <a:t xml:space="preserve"> Precision, Recall, F1, PR AUC, and MCC — all calibrated to the minority (fraud) class.</a:t>
             </a:r>
             <a:endParaRPr lang="en-US" sz="1350" dirty="0"/>
           </a:p>
@@ -9913,7 +9913,7 @@
                 <a:ea typeface="Calibri" pitchFamily="34" charset="-122"/>
                 <a:cs typeface="Calibri" pitchFamily="34" charset="-120"/>
               </a:rPr>
-              <a:t>99th-pct: </a:t>
+              <a:t xml:space="preserve">99th-pct: </a:t>
             </a:r>
             <a:r>
               <a:rPr lang="en-US" sz="1100" dirty="0">
@@ -10005,7 +10005,7 @@
                 <a:ea typeface="Calibri" pitchFamily="34" charset="-122"/>
                 <a:cs typeface="Calibri" pitchFamily="34" charset="-120"/>
               </a:rPr>
-              <a:t>F1-optimal: </a:t>
+              <a:t xml:space="preserve">F1-optimal: </a:t>
             </a:r>
             <a:r>
               <a:rPr lang="en-US" sz="1100" dirty="0">
@@ -11193,7 +11193,7 @@
                           <a:ea typeface="Calibri" pitchFamily="34" charset="-122"/>
                           <a:cs typeface="Calibri" pitchFamily="34" charset="-120"/>
                         </a:rPr>
-                        <a:t>0.898</a:t>
+                        <a:t>0.905</a:t>
                       </a:r>
                       <a:endParaRPr lang="en-US" sz="1100" dirty="0">
                         <a:latin typeface="Calibri" charset="0"/>
@@ -11258,7 +11258,7 @@
                           <a:ea typeface="Calibri" pitchFamily="34" charset="-122"/>
                           <a:cs typeface="Calibri" pitchFamily="34" charset="-120"/>
                         </a:rPr>
-                        <a:t>0.896</a:t>
+                        <a:t>0.903</a:t>
                       </a:r>
                       <a:endParaRPr lang="en-US" sz="1100" dirty="0">
                         <a:latin typeface="Calibri" charset="0"/>
@@ -11323,7 +11323,7 @@
                           <a:ea typeface="Calibri" pitchFamily="34" charset="-122"/>
                           <a:cs typeface="Calibri" pitchFamily="34" charset="-120"/>
                         </a:rPr>
-                        <a:t>0.829</a:t>
+                        <a:t>0.854</a:t>
                       </a:r>
                       <a:endParaRPr lang="en-US" sz="1100" dirty="0">
                         <a:latin typeface="Calibri" charset="0"/>
@@ -11460,7 +11460,7 @@
                           <a:ea typeface="Calibri" pitchFamily="34" charset="-122"/>
                           <a:cs typeface="Calibri" pitchFamily="34" charset="-120"/>
                         </a:rPr>
-                        <a:t>SMOTE + RF</a:t>
+                        <a:t>SMOTE + RF*</a:t>
                       </a:r>
                       <a:endParaRPr lang="en-US" sz="1100" dirty="0">
                         <a:latin typeface="Calibri" charset="0"/>
@@ -11525,7 +11525,7 @@
                           <a:ea typeface="Calibri" pitchFamily="34" charset="-122"/>
                           <a:cs typeface="Calibri" pitchFamily="34" charset="-120"/>
                         </a:rPr>
-                        <a:t>0.907</a:t>
+                        <a:t>—</a:t>
                       </a:r>
                       <a:endParaRPr lang="en-US" sz="1100" dirty="0">
                         <a:latin typeface="Calibri" charset="0"/>
@@ -11590,7 +11590,7 @@
                           <a:ea typeface="Calibri" pitchFamily="34" charset="-122"/>
                           <a:cs typeface="Calibri" pitchFamily="34" charset="-120"/>
                         </a:rPr>
-                        <a:t>0.904</a:t>
+                        <a:t>—</a:t>
                       </a:r>
                       <a:endParaRPr lang="en-US" sz="1100" dirty="0">
                         <a:latin typeface="Calibri" charset="0"/>
@@ -11655,7 +11655,7 @@
                           <a:ea typeface="Calibri" pitchFamily="34" charset="-122"/>
                           <a:cs typeface="Calibri" pitchFamily="34" charset="-120"/>
                         </a:rPr>
-                        <a:t>0.876</a:t>
+                        <a:t>—</a:t>
                       </a:r>
                       <a:endParaRPr lang="en-US" sz="1100" dirty="0">
                         <a:latin typeface="Calibri" charset="0"/>
@@ -11720,7 +11720,7 @@
                           <a:ea typeface="Calibri" pitchFamily="34" charset="-122"/>
                           <a:cs typeface="Calibri" pitchFamily="34" charset="-120"/>
                         </a:rPr>
-                        <a:t>SMOTE</a:t>
+                        <a:t>Not run*</a:t>
                       </a:r>
                       <a:endParaRPr lang="en-US" sz="1100" dirty="0">
                         <a:latin typeface="Calibri" charset="0"/>
@@ -11814,7 +11814,7 @@
                 <a:ea typeface="Calibri" pitchFamily="34" charset="-122"/>
                 <a:cs typeface="Calibri" pitchFamily="34" charset="-120"/>
               </a:rPr>
-              <a:t>Key insight: </a:t>
+              <a:t xml:space="preserve">Key insight: </a:t>
             </a:r>
             <a:r>
               <a:rPr lang="en-US" sz="1250" dirty="0">
@@ -11825,7 +11825,7 @@
                 <a:ea typeface="Calibri" pitchFamily="34" charset="-122"/>
                 <a:cs typeface="Calibri" pitchFamily="34" charset="-120"/>
               </a:rPr>
-              <a:t>SMOTE oversampling + class_weight='balanced' brings F1 from 0.311 (unsupervised) to 0.907 — a 3× improvement when labels are available. The cost is requiring labelled training data, which may not exist at deployment.</a:t>
+              <a:t>class_weight='balanced' RF brings F1 from 0.311 (unsupervised) to 0.905 — a 3× gain when labels are available. *SMOTE variant requires imbalanced-learn (pip install imbalanced-learn). The cost is requiring labelled training data, which may not exist at deployment.</a:t>
             </a:r>
             <a:endParaRPr lang="en-US" sz="1250" dirty="0"/>
           </a:p>
@@ -12368,7 +12368,7 @@
                 <a:ea typeface="Calibri" pitchFamily="34" charset="-122"/>
                 <a:cs typeface="Calibri" pitchFamily="34" charset="-120"/>
               </a:rPr>
-              <a:t>disc_power = 0.391   |sep| = 8.94σ</a:t>
+              <a:t>disc_power = 0.449   |sep| = 7.79σ</a:t>
             </a:r>
             <a:endParaRPr lang="en-US" sz="1200" dirty="0"/>
           </a:p>

</xml_diff>